<commit_message>
Slides: badged PPTX of sd-04-039
</commit_message>
<xml_diff>
--- a/system-design-101/vi/lessons/sd-04-039/slides/sd-04-039.pptx
+++ b/system-design-101/vi/lessons/sd-04-039/slides/sd-04-039.pptx
@@ -7300,8 +7300,8 @@
         </p:nvSpPr>
         <p:spPr>
           <a:xfrm>
-            <a:off x="1295400" y="6286500"/>
-            <a:ext cx="3429000" cy="485775"/>
+            <a:off x="1295400" y="6191250"/>
+            <a:ext cx="3619500" cy="762000"/>
           </a:xfrm>
           <a:prstGeom prst="rect">
             <a:avLst/>
@@ -7317,7 +7317,7 @@
               <a:buNone/>
             </a:pPr>
             <a:r>
-              <a:rPr lang="en-US" sz="2250" dirty="0" spc="-4" kern="0">
+              <a:rPr lang="en-US" sz="2100" dirty="0" spc="-4" kern="0">
                 <a:solidFill>
                   <a:srgbClr val="F3DFB8"/>
                 </a:solidFill>
@@ -7328,7 +7328,7 @@
               <a:t>khóa</a:t>
             </a:r>
             <a:r>
-              <a:rPr lang="en-US" sz="2250" dirty="0" spc="2" kern="0">
+              <a:rPr lang="en-US" sz="2100" dirty="0" spc="-1" kern="0">
                 <a:solidFill>
                   <a:srgbClr val="F3DFB8"/>
                 </a:solidFill>
@@ -7336,10 +7336,10 @@
                 <a:ea typeface="Be Vietnam Pro" pitchFamily="34" charset="-122"/>
                 <a:cs typeface="Be Vietnam Pro" pitchFamily="34" charset="-120"/>
               </a:rPr>
-              <a:t> cần</a:t>
-            </a:r>
-            <a:r>
-              <a:rPr lang="en-US" sz="2250" dirty="0" spc="3" kern="0">
+              <a:t> của</a:t>
+            </a:r>
+            <a:r>
+              <a:rPr lang="en-US" sz="2100" dirty="0" spc="0" kern="0">
                 <a:solidFill>
                   <a:srgbClr val="F3DFB8"/>
                 </a:solidFill>
@@ -7347,10 +7347,16 @@
                 <a:ea typeface="Be Vietnam Pro" pitchFamily="34" charset="-122"/>
                 <a:cs typeface="Be Vietnam Pro" pitchFamily="34" charset="-120"/>
               </a:rPr>
-              <a:t> chỗ</a:t>
-            </a:r>
-            <a:r>
-              <a:rPr lang="en-US" sz="2250" dirty="0" spc="0" kern="0">
+              <a:t> s3,</a:t>
+            </a:r>
+            <a:endParaRPr lang="en-US" sz="2100" dirty="0"/>
+          </a:p>
+          <a:p>
+            <a:pPr algn="l" indent="0" marL="0">
+              <a:buNone/>
+            </a:pPr>
+            <a:r>
+              <a:rPr lang="en-US" sz="2100" dirty="0" spc="2" kern="0">
                 <a:solidFill>
                   <a:srgbClr val="F3DFB8"/>
                 </a:solidFill>
@@ -7358,9 +7364,53 @@
                 <a:ea typeface="Be Vietnam Pro" pitchFamily="34" charset="-122"/>
                 <a:cs typeface="Be Vietnam Pro" pitchFamily="34" charset="-120"/>
               </a:rPr>
-              <a:t> mới</a:t>
-            </a:r>
-            <a:endParaRPr lang="en-US" sz="2250" dirty="0"/>
+              <a:t>khi</a:t>
+            </a:r>
+            <a:r>
+              <a:rPr lang="en-US" sz="2100" dirty="0" spc="-1" kern="0">
+                <a:solidFill>
+                  <a:srgbClr val="F3DFB8"/>
+                </a:solidFill>
+                <a:latin typeface="Be Vietnam Pro" pitchFamily="34" charset="0"/>
+                <a:ea typeface="Be Vietnam Pro" pitchFamily="34" charset="-122"/>
+                <a:cs typeface="Be Vietnam Pro" pitchFamily="34" charset="-120"/>
+              </a:rPr>
+              <a:t> mỗi</a:t>
+            </a:r>
+            <a:r>
+              <a:rPr lang="en-US" sz="2100" dirty="0" spc="-10" kern="0">
+                <a:solidFill>
+                  <a:srgbClr val="F3DFB8"/>
+                </a:solidFill>
+                <a:latin typeface="Be Vietnam Pro" pitchFamily="34" charset="0"/>
+                <a:ea typeface="Be Vietnam Pro" pitchFamily="34" charset="-122"/>
+                <a:cs typeface="Be Vietnam Pro" pitchFamily="34" charset="-120"/>
+              </a:rPr>
+              <a:t> máy</a:t>
+            </a:r>
+            <a:r>
+              <a:rPr lang="en-US" sz="2100" dirty="0" spc="-5" kern="0">
+                <a:solidFill>
+                  <a:srgbClr val="F3DFB8"/>
+                </a:solidFill>
+                <a:latin typeface="Be Vietnam Pro" pitchFamily="34" charset="0"/>
+                <a:ea typeface="Be Vietnam Pro" pitchFamily="34" charset="-122"/>
+                <a:cs typeface="Be Vietnam Pro" pitchFamily="34" charset="-120"/>
+              </a:rPr>
+              <a:t> 1</a:t>
+            </a:r>
+            <a:r>
+              <a:rPr lang="en-US" sz="2100" dirty="0" spc="18" kern="0">
+                <a:solidFill>
+                  <a:srgbClr val="F3DFB8"/>
+                </a:solidFill>
+                <a:latin typeface="Be Vietnam Pro" pitchFamily="34" charset="0"/>
+                <a:ea typeface="Be Vietnam Pro" pitchFamily="34" charset="-122"/>
+                <a:cs typeface="Be Vietnam Pro" pitchFamily="34" charset="-120"/>
+              </a:rPr>
+              <a:t> điểm</a:t>
+            </a:r>
+            <a:endParaRPr lang="en-US" sz="2100" dirty="0"/>
           </a:p>
         </p:txBody>
       </p:sp>
@@ -7748,6 +7798,39 @@
               <a:buNone/>
             </a:pPr>
             <a:r>
+              <a:rPr lang="en-US" sz="3000" b="1" dirty="0" spc="-10" kern="0">
+                <a:solidFill>
+                  <a:srgbClr val="14161C"/>
+                </a:solidFill>
+                <a:latin typeface="Be Vietnam Pro" pitchFamily="34" charset="0"/>
+                <a:ea typeface="Be Vietnam Pro" pitchFamily="34" charset="-122"/>
+                <a:cs typeface="Be Vietnam Pro" pitchFamily="34" charset="-120"/>
+              </a:rPr>
+              <a:t>Khóa</a:t>
+            </a:r>
+            <a:r>
+              <a:rPr lang="en-US" sz="3000" b="1" dirty="0" spc="1" kern="0">
+                <a:solidFill>
+                  <a:srgbClr val="14161C"/>
+                </a:solidFill>
+                <a:latin typeface="Be Vietnam Pro" pitchFamily="34" charset="0"/>
+                <a:ea typeface="Be Vietnam Pro" pitchFamily="34" charset="-122"/>
+                <a:cs typeface="Be Vietnam Pro" pitchFamily="34" charset="-120"/>
+              </a:rPr>
+              <a:t> của</a:t>
+            </a:r>
+            <a:r>
+              <a:rPr lang="en-US" sz="3000" b="1" dirty="0" spc="2" kern="0">
+                <a:solidFill>
+                  <a:srgbClr val="14161C"/>
+                </a:solidFill>
+                <a:latin typeface="Be Vietnam Pro" pitchFamily="34" charset="0"/>
+                <a:ea typeface="Be Vietnam Pro" pitchFamily="34" charset="-122"/>
+                <a:cs typeface="Be Vietnam Pro" pitchFamily="34" charset="-120"/>
+              </a:rPr>
+              <a:t> s3</a:t>
+            </a:r>
+            <a:r>
               <a:rPr lang="en-US" sz="3000" b="1" dirty="0" spc="0" kern="0">
                 <a:solidFill>
                   <a:srgbClr val="14161C"/>
@@ -7756,21 +7839,21 @@
                 <a:ea typeface="Be Vietnam Pro" pitchFamily="34" charset="-122"/>
                 <a:cs typeface="Be Vietnam Pro" pitchFamily="34" charset="-120"/>
               </a:rPr>
-              <a:t>Chia</a:t>
+              <a:t> chia</a:t>
+            </a:r>
+            <a:r>
+              <a:rPr lang="en-US" sz="3000" b="1" dirty="0" spc="-5" kern="0">
+                <a:solidFill>
+                  <a:srgbClr val="14161C"/>
+                </a:solidFill>
+                <a:latin typeface="Be Vietnam Pro" pitchFamily="34" charset="0"/>
+                <a:ea typeface="Be Vietnam Pro" pitchFamily="34" charset="-122"/>
+                <a:cs typeface="Be Vietnam Pro" pitchFamily="34" charset="-120"/>
+              </a:rPr>
+              <a:t> cho</a:t>
             </a:r>
             <a:r>
               <a:rPr lang="en-US" sz="3000" b="1" dirty="0" spc="-4" kern="0">
-                <a:solidFill>
-                  <a:srgbClr val="14161C"/>
-                </a:solidFill>
-                <a:latin typeface="Be Vietnam Pro" pitchFamily="34" charset="0"/>
-                <a:ea typeface="Be Vietnam Pro" pitchFamily="34" charset="-122"/>
-                <a:cs typeface="Be Vietnam Pro" pitchFamily="34" charset="-120"/>
-              </a:rPr>
-              <a:t> cho</a:t>
-            </a:r>
-            <a:r>
-              <a:rPr lang="en-US" sz="3000" b="1" dirty="0" spc="-5" kern="0">
                 <a:solidFill>
                   <a:srgbClr val="14161C"/>
                 </a:solidFill>

</xml_diff>